<commit_message>
Clarify the China objection and the discussion guide wording
- Site (반대의 눈 card, source B), PPT slide 7: replace the vague
  "중국과의 관계" with the 상소's actual point, that China might
  criticize the new script (事大慕華).
- Site 토의와 평가 and slide 7 notes: replace "놓친 사람의 입장" with
  an explicit question about who is inconvenienced by each argument.
- Regenerate slide 7 preview image and thumbnail.

Co-Authored-By: Claude Opus 5.5 <noreply@anthropic.com>
Claude-Session: https://claude.ai/code/session_01Pmh6PhJww4VXSAKX9u9GHE
</commit_message>
<xml_diff>
--- a/files/hangeul-lesson.pptx
+++ b/files/hangeul-lesson.pptx
@@ -2001,7 +2001,7 @@
               <a:rPr lang="en-US" dirty="0"/>
               <a:t>사료 B: 『세종실록』 103권, 세종 26년 2월 20일(음력). 최만리·신석조·김문 등 일부 신하들이 올린 상소이며 집현전 전체가 반대한 것은 아닙니다. 실제 상소에는 더 많은 논점이 있으나 두 가지로 줄였습니다.
 세종의 대답은 그림책 2장의 대사입니다. 실록의 세종 답변도 이두와 새 글자 모두 백성을 편하게 하려는 것이라는 취지이며, 설총은 옳고 임금은 그르다는 것이냐고 되묻습니다(원문은 반문 형식, 정확한 국역은 링크에서 확인).
-반대한 사람을 "나쁜 사람"으로 단순화하지 않고, 주장의 근거와 놓친 사람의 입장을 묻습니다.
+반대한 사람을 "나쁜 사람"으로 단순화하지 않고, 각 주장의 근거가 무엇인지와 그 주장대로 되면 누가 불편을 겪는지(예: 글을 모르는 백성)를 묻습니다.
 https://sillok.history.go.kr/id/kda_12602020_001</a:t>
             </a:r>
             <a:endParaRPr lang="en-US" dirty="0"/>
@@ -14267,7 +14267,7 @@
                   <a:schemeClr val="tx1"/>
                 </a:solidFill>
               </a:rPr>
-              <a:t>중국과의 관계가 걱정돼요</a:t>
+              <a:t>중국이 알면 비난할까 걱정돼요</a:t>
             </a:r>
             <a:endParaRPr lang="en-US" sz="2000" dirty="0"/>
           </a:p>

</xml_diff>